<commit_message>
Reconcile weekly resource mappings
</commit_message>
<xml_diff>
--- a/STARLAB_Slide_Decks_All/05_Building_a_Formal_Research_Plan_2.0.pptx
+++ b/STARLAB_Slide_Decks_All/05_Building_a_Formal_Research_Plan_2.0.pptx
@@ -2,42 +2,42 @@
 <file path=ppt/presentation.xml><?xml version="1.0" encoding="utf-8"?>
 <p:presentation xmlns:p="http://schemas.openxmlformats.org/presentationml/2006/main" embedTrueTypeFonts="1" saveSubsetFonts="0">
   <p:sldMasterIdLst>
-    <p:sldMasterId xmlns:r="http://schemas.openxmlformats.org/officeDocument/2006/relationships" id="2147483648" r:id="R5b7b23c390d04b35"/>
+    <p:sldMasterId xmlns:r="http://schemas.openxmlformats.org/officeDocument/2006/relationships" id="2147483648" r:id="Ra4fefd222c7e45c0"/>
   </p:sldMasterIdLst>
   <p:notesMasterIdLst>
-    <p:notesMasterId xmlns:r="http://schemas.openxmlformats.org/officeDocument/2006/relationships" r:id="Rfc90465ff9d64b65"/>
+    <p:notesMasterId xmlns:r="http://schemas.openxmlformats.org/officeDocument/2006/relationships" r:id="R63e84b82d1f448a6"/>
   </p:notesMasterIdLst>
   <p:sldIdLst>
-    <p:sldId xmlns:r="http://schemas.openxmlformats.org/officeDocument/2006/relationships" id="256" r:id="Rcd47abd4563b4506"/>
-    <p:sldId xmlns:r="http://schemas.openxmlformats.org/officeDocument/2006/relationships" id="257" r:id="Rb6e8a3d8b1b14b83"/>
-    <p:sldId xmlns:r="http://schemas.openxmlformats.org/officeDocument/2006/relationships" id="258" r:id="Ref2d599967b24692"/>
-    <p:sldId xmlns:r="http://schemas.openxmlformats.org/officeDocument/2006/relationships" id="259" r:id="R91caa1ece3db48e9"/>
-    <p:sldId xmlns:r="http://schemas.openxmlformats.org/officeDocument/2006/relationships" id="260" r:id="Re7b6477756864802"/>
-    <p:sldId xmlns:r="http://schemas.openxmlformats.org/officeDocument/2006/relationships" id="261" r:id="R9e03643539614c4a"/>
-    <p:sldId xmlns:r="http://schemas.openxmlformats.org/officeDocument/2006/relationships" id="262" r:id="R4d554a7372d04d4e"/>
-    <p:sldId xmlns:r="http://schemas.openxmlformats.org/officeDocument/2006/relationships" id="263" r:id="R9bf75e11325f49ed"/>
-    <p:sldId xmlns:r="http://schemas.openxmlformats.org/officeDocument/2006/relationships" id="264" r:id="R4a292ec2c5b54f1b"/>
-    <p:sldId xmlns:r="http://schemas.openxmlformats.org/officeDocument/2006/relationships" id="265" r:id="R485c6c57eb7646e1"/>
-    <p:sldId xmlns:r="http://schemas.openxmlformats.org/officeDocument/2006/relationships" id="266" r:id="Ra4b5f47e79e14877"/>
-    <p:sldId xmlns:r="http://schemas.openxmlformats.org/officeDocument/2006/relationships" id="267" r:id="R3cfe5c280b8148be"/>
-    <p:sldId xmlns:r="http://schemas.openxmlformats.org/officeDocument/2006/relationships" id="268" r:id="Rd599bc34e808439d"/>
-    <p:sldId xmlns:r="http://schemas.openxmlformats.org/officeDocument/2006/relationships" id="269" r:id="Rd25d4066175f4fed"/>
-    <p:sldId xmlns:r="http://schemas.openxmlformats.org/officeDocument/2006/relationships" id="270" r:id="Ra20e07c9e9c249dd"/>
-    <p:sldId xmlns:r="http://schemas.openxmlformats.org/officeDocument/2006/relationships" id="271" r:id="Rd0d4db4544684445"/>
-    <p:sldId xmlns:r="http://schemas.openxmlformats.org/officeDocument/2006/relationships" id="272" r:id="R527b081a10f44bdb"/>
-    <p:sldId xmlns:r="http://schemas.openxmlformats.org/officeDocument/2006/relationships" id="273" r:id="Rcbfdcacea43b4881"/>
-    <p:sldId xmlns:r="http://schemas.openxmlformats.org/officeDocument/2006/relationships" id="274" r:id="Rcf4e07c732724a91"/>
-    <p:sldId xmlns:r="http://schemas.openxmlformats.org/officeDocument/2006/relationships" id="275" r:id="Racadf7beb6d94971"/>
-    <p:sldId xmlns:r="http://schemas.openxmlformats.org/officeDocument/2006/relationships" id="276" r:id="Rd40571c77945486c"/>
-    <p:sldId xmlns:r="http://schemas.openxmlformats.org/officeDocument/2006/relationships" id="277" r:id="Rf4fdfa5c88334508"/>
+    <p:sldId xmlns:r="http://schemas.openxmlformats.org/officeDocument/2006/relationships" id="256" r:id="R9f3b7e48421c4fab"/>
+    <p:sldId xmlns:r="http://schemas.openxmlformats.org/officeDocument/2006/relationships" id="257" r:id="Rfac9065864df4794"/>
+    <p:sldId xmlns:r="http://schemas.openxmlformats.org/officeDocument/2006/relationships" id="258" r:id="Rf80a6f571f164bb5"/>
+    <p:sldId xmlns:r="http://schemas.openxmlformats.org/officeDocument/2006/relationships" id="259" r:id="R0d491f52e191429b"/>
+    <p:sldId xmlns:r="http://schemas.openxmlformats.org/officeDocument/2006/relationships" id="260" r:id="R2b936fc93f9b4045"/>
+    <p:sldId xmlns:r="http://schemas.openxmlformats.org/officeDocument/2006/relationships" id="261" r:id="Rbea63bebb65d4729"/>
+    <p:sldId xmlns:r="http://schemas.openxmlformats.org/officeDocument/2006/relationships" id="262" r:id="R9e37c9710260467d"/>
+    <p:sldId xmlns:r="http://schemas.openxmlformats.org/officeDocument/2006/relationships" id="263" r:id="R302ab665a468407f"/>
+    <p:sldId xmlns:r="http://schemas.openxmlformats.org/officeDocument/2006/relationships" id="264" r:id="R1f5c9d46500d4772"/>
+    <p:sldId xmlns:r="http://schemas.openxmlformats.org/officeDocument/2006/relationships" id="265" r:id="R6cb73240ac1f46f4"/>
+    <p:sldId xmlns:r="http://schemas.openxmlformats.org/officeDocument/2006/relationships" id="266" r:id="R68c147e407d0427f"/>
+    <p:sldId xmlns:r="http://schemas.openxmlformats.org/officeDocument/2006/relationships" id="267" r:id="Rfe9336ff66bc4441"/>
+    <p:sldId xmlns:r="http://schemas.openxmlformats.org/officeDocument/2006/relationships" id="268" r:id="R824ac0acd1bf494c"/>
+    <p:sldId xmlns:r="http://schemas.openxmlformats.org/officeDocument/2006/relationships" id="269" r:id="R2e822fdd453b4ce7"/>
+    <p:sldId xmlns:r="http://schemas.openxmlformats.org/officeDocument/2006/relationships" id="270" r:id="R62abb5c9fc17436b"/>
+    <p:sldId xmlns:r="http://schemas.openxmlformats.org/officeDocument/2006/relationships" id="271" r:id="Rbd1d37dea55340ac"/>
+    <p:sldId xmlns:r="http://schemas.openxmlformats.org/officeDocument/2006/relationships" id="272" r:id="Rb79556aecb1d41fb"/>
+    <p:sldId xmlns:r="http://schemas.openxmlformats.org/officeDocument/2006/relationships" id="273" r:id="Ra63059379f7744f4"/>
+    <p:sldId xmlns:r="http://schemas.openxmlformats.org/officeDocument/2006/relationships" id="274" r:id="Rb30a9db5a4814dcf"/>
+    <p:sldId xmlns:r="http://schemas.openxmlformats.org/officeDocument/2006/relationships" id="275" r:id="R3f9c650f9b504f74"/>
+    <p:sldId xmlns:r="http://schemas.openxmlformats.org/officeDocument/2006/relationships" id="276" r:id="R36c64dd0842f472a"/>
+    <p:sldId xmlns:r="http://schemas.openxmlformats.org/officeDocument/2006/relationships" id="277" r:id="Rd5471cc357ac419c"/>
   </p:sldIdLst>
   <p:sldSz cx="12192000" cy="6858000"/>
   <p:notesSz cx="6858000" cy="9144000"/>
   <p:embeddedFontLst>
     <p:embeddedFont>
       <p:font typeface="Play"/>
-      <p:regular xmlns:r="http://schemas.openxmlformats.org/officeDocument/2006/relationships" r:id="Rf3da1ec14a3c4b97"/>
-      <p:bold xmlns:r="http://schemas.openxmlformats.org/officeDocument/2006/relationships" r:id="Rf027608d47a2442e"/>
+      <p:regular xmlns:r="http://schemas.openxmlformats.org/officeDocument/2006/relationships" r:id="R39f68eddf52d4d7c"/>
+      <p:bold xmlns:r="http://schemas.openxmlformats.org/officeDocument/2006/relationships" r:id="Ra50fcc9c8a6a4ed2"/>
     </p:embeddedFont>
   </p:embeddedFontLst>
   <p:defaultTextStyle>
@@ -597,76 +597,245 @@
               <a:buNone/>
             </a:pPr>
             <a:r>
-              <a:t>Teacher notes:</a:t>
-            </a:r>
-            <a:br/>
-            <a:r>
-              <a:t>Use this title slide as students enter. This deck moves students from “interesting idea” to an approved plan for safe, feasible research. Frame the research plan as the launch checklist that makes authentic research possible.</a:t>
-            </a:r>
-            <a:br/>
-            <a:br/>
-            <a:r>
-              <a:t>Resource alignment:</a:t>
-            </a:r>
-            <a:br/>
-            <a:r>
-              <a:t>Required print materials for this deck:</a:t>
-            </a:r>
-            <a:br/>
-            <a:r>
-              <a:t>• Unit 2 Student Handout 1: Project Refinement Workshop</a:t>
-            </a:r>
-            <a:br/>
-            <a:r>
-              <a:t>• Unit 2 Student Handout 2: Background Research Notes</a:t>
-            </a:r>
-            <a:br/>
-            <a:r>
-              <a:t>• Unit 2 Student Handout 3: Hypothesis and Design Criteria Builder</a:t>
-            </a:r>
-            <a:br/>
-            <a:r>
-              <a:t>• Unit 2 Student Handout 4: Variables, Controls, Criteria, and Constraints Organizer</a:t>
-            </a:r>
-            <a:br/>
-            <a:r>
-              <a:t>• Unit 2 Student Handout 5: Evidence Planning Tool</a:t>
-            </a:r>
-            <a:br/>
-            <a:r>
-              <a:t>• Unit 2 Student Handout 6: Materials and Equipment Planner</a:t>
-            </a:r>
-            <a:br/>
-            <a:r>
-              <a:t>• Unit 2 Student Handout 7: Procedure and Testing Protocol Builder</a:t>
-            </a:r>
-            <a:br/>
-            <a:r>
-              <a:t>• Unit 2 Student Handout 8: Data Collection Plan</a:t>
-            </a:r>
-            <a:br/>
-            <a:r>
-              <a:t>• Unit 2 Student Handout 9: Safety and Risk Assessment</a:t>
-            </a:r>
-            <a:br/>
-            <a:r>
-              <a:t>• Unit 2 Student Handout 10: Ethics and Approval Screening</a:t>
-            </a:r>
-            <a:br/>
-            <a:r>
-              <a:t>• Unit 2 Student Handout 11: Project Timeline Planner</a:t>
-            </a:r>
-            <a:br/>
-            <a:r>
-              <a:t>• Unit 2 Student Handout 12: Formal Research Plan Template</a:t>
-            </a:r>
-            <a:br/>
-            <a:r>
-              <a:t>• Unit 2 Student Handout 13: Research Plan Conference Form</a:t>
-            </a:r>
-            <a:br/>
-            <a:r>
-              <a:t>• Unit 2 Appendix H: Project Approval Checklist</a:t>
+              <a:t>PRIMARY TEACHING MOMENT</a:t>
+            </a:r>
+          </a:p>
+          <a:p xmlns:a="http://schemas.openxmlformats.org/drawingml/2006/main">
+            <a:pPr marL="0" indent="0" algn="l">
+              <a:spcBef>
+                <a:spcPts val="0"/>
+              </a:spcBef>
+              <a:spcAft>
+                <a:spcPts val="0"/>
+              </a:spcAft>
+              <a:buNone/>
+            </a:pPr>
+            <a:r>
+              <a:t>Unit 2, Weeks 3-4</a:t>
+            </a:r>
+          </a:p>
+          <a:p xmlns:a="http://schemas.openxmlformats.org/drawingml/2006/main">
+            <a:pPr marL="0" indent="0" algn="l">
+              <a:spcBef>
+                <a:spcPts val="0"/>
+              </a:spcBef>
+              <a:spcAft>
+                <a:spcPts val="0"/>
+              </a:spcAft>
+              <a:buNone/>
+            </a:pPr>
+            <a:r>
+              <a:t/>
+            </a:r>
+          </a:p>
+          <a:p xmlns:a="http://schemas.openxmlformats.org/drawingml/2006/main">
+            <a:pPr marL="0" indent="0" algn="l">
+              <a:spcBef>
+                <a:spcPts val="0"/>
+              </a:spcBef>
+              <a:spcAft>
+                <a:spcPts val="0"/>
+              </a:spcAft>
+              <a:buNone/>
+            </a:pPr>
+            <a:r>
+              <a:t>REQUIRED WEEK 3 MATERIALS</a:t>
+            </a:r>
+          </a:p>
+          <a:p xmlns:a="http://schemas.openxmlformats.org/drawingml/2006/main">
+            <a:pPr marL="0" indent="0" algn="l">
+              <a:spcBef>
+                <a:spcPts val="0"/>
+              </a:spcBef>
+              <a:spcAft>
+                <a:spcPts val="0"/>
+              </a:spcAft>
+              <a:buNone/>
+            </a:pPr>
+            <a:r>
+              <a:t>- Unit 2 Student Handouts 1-5</a:t>
+            </a:r>
+          </a:p>
+          <a:p xmlns:a="http://schemas.openxmlformats.org/drawingml/2006/main">
+            <a:pPr marL="0" indent="0" algn="l">
+              <a:spcBef>
+                <a:spcPts val="0"/>
+              </a:spcBef>
+              <a:spcAft>
+                <a:spcPts val="0"/>
+              </a:spcAft>
+              <a:buNone/>
+            </a:pPr>
+            <a:r>
+              <a:t>- Unit 2 Appendices A-D</a:t>
+            </a:r>
+          </a:p>
+          <a:p xmlns:a="http://schemas.openxmlformats.org/drawingml/2006/main">
+            <a:pPr marL="0" indent="0" algn="l">
+              <a:spcBef>
+                <a:spcPts val="0"/>
+              </a:spcBef>
+              <a:spcAft>
+                <a:spcPts val="0"/>
+              </a:spcAft>
+              <a:buNone/>
+            </a:pPr>
+            <a:r>
+              <a:t/>
+            </a:r>
+          </a:p>
+          <a:p xmlns:a="http://schemas.openxmlformats.org/drawingml/2006/main">
+            <a:pPr marL="0" indent="0" algn="l">
+              <a:spcBef>
+                <a:spcPts val="0"/>
+              </a:spcBef>
+              <a:spcAft>
+                <a:spcPts val="0"/>
+              </a:spcAft>
+              <a:buNone/>
+            </a:pPr>
+            <a:r>
+              <a:t>REQUIRED WEEK 4 MATERIALS</a:t>
+            </a:r>
+          </a:p>
+          <a:p xmlns:a="http://schemas.openxmlformats.org/drawingml/2006/main">
+            <a:pPr marL="0" indent="0" algn="l">
+              <a:spcBef>
+                <a:spcPts val="0"/>
+              </a:spcBef>
+              <a:spcAft>
+                <a:spcPts val="0"/>
+              </a:spcAft>
+              <a:buNone/>
+            </a:pPr>
+            <a:r>
+              <a:t>- Unit 2 Student Handouts 6-13</a:t>
+            </a:r>
+          </a:p>
+          <a:p xmlns:a="http://schemas.openxmlformats.org/drawingml/2006/main">
+            <a:pPr marL="0" indent="0" algn="l">
+              <a:spcBef>
+                <a:spcPts val="0"/>
+              </a:spcBef>
+              <a:spcAft>
+                <a:spcPts val="0"/>
+              </a:spcAft>
+              <a:buNone/>
+            </a:pPr>
+            <a:r>
+              <a:t>- Unit 2 Appendices E-H</a:t>
+            </a:r>
+          </a:p>
+          <a:p xmlns:a="http://schemas.openxmlformats.org/drawingml/2006/main">
+            <a:pPr marL="0" indent="0" algn="l">
+              <a:spcBef>
+                <a:spcPts val="0"/>
+              </a:spcBef>
+              <a:spcAft>
+                <a:spcPts val="0"/>
+              </a:spcAft>
+              <a:buNone/>
+            </a:pPr>
+            <a:r>
+              <a:t/>
+            </a:r>
+          </a:p>
+          <a:p xmlns:a="http://schemas.openxmlformats.org/drawingml/2006/main">
+            <a:pPr marL="0" indent="0" algn="l">
+              <a:spcBef>
+                <a:spcPts val="0"/>
+              </a:spcBef>
+              <a:spcAft>
+                <a:spcPts val="0"/>
+              </a:spcAft>
+              <a:buNone/>
+            </a:pPr>
+            <a:r>
+              <a:t>OPTIONAL / TEACHER REFERENCE FOR WEEK 4</a:t>
+            </a:r>
+          </a:p>
+          <a:p xmlns:a="http://schemas.openxmlformats.org/drawingml/2006/main">
+            <a:pPr marL="0" indent="0" algn="l">
+              <a:spcBef>
+                <a:spcPts val="0"/>
+              </a:spcBef>
+              <a:spcAft>
+                <a:spcPts val="0"/>
+              </a:spcAft>
+              <a:buNone/>
+            </a:pPr>
+            <a:r>
+              <a:t>- Unit 2 Appendix I: Mentor Feedback Request Template</a:t>
+            </a:r>
+          </a:p>
+          <a:p xmlns:a="http://schemas.openxmlformats.org/drawingml/2006/main">
+            <a:pPr marL="0" indent="0" algn="l">
+              <a:spcBef>
+                <a:spcPts val="0"/>
+              </a:spcBef>
+              <a:spcAft>
+                <a:spcPts val="0"/>
+              </a:spcAft>
+              <a:buNone/>
+            </a:pPr>
+            <a:r>
+              <a:t>- Unit 2 Appendix J: Sample Completed Planning Excerpt</a:t>
+            </a:r>
+          </a:p>
+          <a:p xmlns:a="http://schemas.openxmlformats.org/drawingml/2006/main">
+            <a:pPr marL="0" indent="0" algn="l">
+              <a:spcBef>
+                <a:spcPts val="0"/>
+              </a:spcBef>
+              <a:spcAft>
+                <a:spcPts val="0"/>
+              </a:spcAft>
+              <a:buNone/>
+            </a:pPr>
+            <a:r>
+              <a:t>- District-supplied approval and safety forms as applicable</a:t>
+            </a:r>
+          </a:p>
+          <a:p xmlns:a="http://schemas.openxmlformats.org/drawingml/2006/main">
+            <a:pPr marL="0" indent="0" algn="l">
+              <a:spcBef>
+                <a:spcPts val="0"/>
+              </a:spcBef>
+              <a:spcAft>
+                <a:spcPts val="0"/>
+              </a:spcAft>
+              <a:buNone/>
+            </a:pPr>
+            <a:r>
+              <a:t/>
+            </a:r>
+          </a:p>
+          <a:p xmlns:a="http://schemas.openxmlformats.org/drawingml/2006/main">
+            <a:pPr marL="0" indent="0" algn="l">
+              <a:spcBef>
+                <a:spcPts val="0"/>
+              </a:spcBef>
+              <a:spcAft>
+                <a:spcPts val="0"/>
+              </a:spcAft>
+              <a:buNone/>
+            </a:pPr>
+            <a:r>
+              <a:t>RESOURCE ALIGNMENT</a:t>
+            </a:r>
+          </a:p>
+          <a:p xmlns:a="http://schemas.openxmlformats.org/drawingml/2006/main">
+            <a:pPr marL="0" indent="0" algn="l">
+              <a:spcBef>
+                <a:spcPts val="0"/>
+              </a:spcBef>
+              <a:spcAft>
+                <a:spcPts val="0"/>
+              </a:spcAft>
+              <a:buNone/>
+            </a:pPr>
+            <a:r>
+              <a:t>Keep the Week 3 refinement packet separate from the Week 4 formal-plan and approval packet. The Project Approval Tracker is the final authority on whether testing may begin.</a:t>
             </a:r>
           </a:p>
         </p:txBody>
@@ -2711,7 +2880,7 @@
   </p:cSld>
   <p:clrMap bg1="lt1" tx1="dk1" bg2="dk2" tx2="lt2" accent1="accent1" accent2="accent2" accent3="accent3" accent4="accent4" accent5="accent5" accent6="accent6" hlink="hlink" folHlink="folHlink"/>
   <p:sldLayoutIdLst>
-    <p:sldLayoutId xmlns:r="http://schemas.openxmlformats.org/officeDocument/2006/relationships" id="2147483649" r:id="R4d54e44df953448d"/>
+    <p:sldLayoutId xmlns:r="http://schemas.openxmlformats.org/officeDocument/2006/relationships" id="2147483649" r:id="Rffd2c7061aa64892"/>
   </p:sldLayoutIdLst>
   <p:hf sldNum="0" hdr="0" ftr="0" dt="0"/>
   <p:txStyles>
@@ -3834,7 +4003,7 @@
           <p:nvPr/>
         </p:nvPicPr>
         <p:blipFill rotWithShape="1">
-          <a:blip xmlns:r="http://schemas.openxmlformats.org/officeDocument/2006/relationships" xmlns:a="http://schemas.openxmlformats.org/drawingml/2006/main" r:embed="Re2704b67fadb4b7a">
+          <a:blip xmlns:r="http://schemas.openxmlformats.org/officeDocument/2006/relationships" xmlns:a="http://schemas.openxmlformats.org/drawingml/2006/main" r:embed="R6b2ed75c973e4dc4">
             <a:alphaModFix/>
           </a:blip>
           <a:srcRect xmlns:a="http://schemas.openxmlformats.org/drawingml/2006/main" l="0" t="0" r="0" b="0"/>
@@ -4489,7 +4658,7 @@
       </p:sp>
       <p:cxnSp>
         <p:nvCxnSpPr>
-          <p:cNvPr id="316" name="Google Shape;287;p12"/>
+          <p:cNvPr id="323" name="Google Shape;287;p12"/>
           <p:cNvCxnSpPr/>
           <p:nvPr/>
         </p:nvCxnSpPr>
@@ -6173,7 +6342,7 @@
       </p:sp>
       <p:cxnSp>
         <p:nvCxnSpPr>
-          <p:cNvPr id="352" name="Google Shape;321;p13"/>
+          <p:cNvPr id="359" name="Google Shape;321;p13"/>
           <p:cNvCxnSpPr/>
           <p:nvPr/>
         </p:nvCxnSpPr>
@@ -7973,7 +8142,7 @@
       </p:sp>
       <p:cxnSp>
         <p:nvCxnSpPr>
-          <p:cNvPr id="386" name="Google Shape;357;p14"/>
+          <p:cNvPr id="393" name="Google Shape;357;p14"/>
           <p:cNvCxnSpPr/>
           <p:nvPr/>
         </p:nvCxnSpPr>
@@ -9657,7 +9826,7 @@
       </p:sp>
       <p:cxnSp>
         <p:nvCxnSpPr>
-          <p:cNvPr id="413" name="Google Shape;391;p15"/>
+          <p:cNvPr id="420" name="Google Shape;391;p15"/>
           <p:cNvCxnSpPr/>
           <p:nvPr/>
         </p:nvCxnSpPr>
@@ -11021,7 +11190,7 @@
       </p:sp>
       <p:cxnSp>
         <p:nvCxnSpPr>
-          <p:cNvPr id="448" name="Google Shape;418;p16"/>
+          <p:cNvPr id="455" name="Google Shape;418;p16"/>
           <p:cNvCxnSpPr/>
           <p:nvPr/>
         </p:nvCxnSpPr>
@@ -12766,7 +12935,7 @@
       </p:sp>
       <p:cxnSp>
         <p:nvCxnSpPr>
-          <p:cNvPr id="493" name="Google Shape;453;p17"/>
+          <p:cNvPr id="522" name="Google Shape;453;p17"/>
           <p:cNvCxnSpPr/>
           <p:nvPr/>
         </p:nvCxnSpPr>
@@ -12968,7 +13137,7 @@
       </p:sp>
       <p:cxnSp>
         <p:nvCxnSpPr>
-          <p:cNvPr id="497" name="Google Shape;457;p17"/>
+          <p:cNvPr id="526" name="Google Shape;457;p17"/>
           <p:cNvCxnSpPr/>
           <p:nvPr/>
         </p:nvCxnSpPr>
@@ -13109,7 +13278,7 @@
       </p:sp>
       <p:cxnSp>
         <p:nvCxnSpPr>
-          <p:cNvPr id="500" name="Google Shape;460;p17"/>
+          <p:cNvPr id="529" name="Google Shape;460;p17"/>
           <p:cNvCxnSpPr/>
           <p:nvPr/>
         </p:nvCxnSpPr>
@@ -13250,7 +13419,7 @@
       </p:sp>
       <p:cxnSp>
         <p:nvCxnSpPr>
-          <p:cNvPr id="503" name="Google Shape;463;p17"/>
+          <p:cNvPr id="532" name="Google Shape;463;p17"/>
           <p:cNvCxnSpPr/>
           <p:nvPr/>
         </p:nvCxnSpPr>
@@ -13391,7 +13560,7 @@
       </p:sp>
       <p:cxnSp>
         <p:nvCxnSpPr>
-          <p:cNvPr id="506" name="Google Shape;466;p17"/>
+          <p:cNvPr id="535" name="Google Shape;466;p17"/>
           <p:cNvCxnSpPr/>
           <p:nvPr/>
         </p:nvCxnSpPr>
@@ -13532,7 +13701,7 @@
       </p:sp>
       <p:cxnSp>
         <p:nvCxnSpPr>
-          <p:cNvPr id="509" name="Google Shape;469;p17"/>
+          <p:cNvPr id="538" name="Google Shape;469;p17"/>
           <p:cNvCxnSpPr/>
           <p:nvPr/>
         </p:nvCxnSpPr>
@@ -13673,7 +13842,7 @@
       </p:sp>
       <p:cxnSp>
         <p:nvCxnSpPr>
-          <p:cNvPr id="512" name="Google Shape;472;p17"/>
+          <p:cNvPr id="541" name="Google Shape;472;p17"/>
           <p:cNvCxnSpPr/>
           <p:nvPr/>
         </p:nvCxnSpPr>
@@ -13814,7 +13983,7 @@
       </p:sp>
       <p:cxnSp>
         <p:nvCxnSpPr>
-          <p:cNvPr id="515" name="Google Shape;475;p17"/>
+          <p:cNvPr id="544" name="Google Shape;475;p17"/>
           <p:cNvCxnSpPr/>
           <p:nvPr/>
         </p:nvCxnSpPr>
@@ -14857,7 +15026,7 @@
       </p:sp>
       <p:cxnSp>
         <p:nvCxnSpPr>
-          <p:cNvPr id="526" name="Google Shape;498;p18"/>
+          <p:cNvPr id="533" name="Google Shape;498;p18"/>
           <p:cNvCxnSpPr/>
           <p:nvPr/>
         </p:nvCxnSpPr>
@@ -16480,7 +16649,7 @@
       </p:sp>
       <p:cxnSp>
         <p:nvCxnSpPr>
-          <p:cNvPr id="563" name="Google Shape;531;p19"/>
+          <p:cNvPr id="570" name="Google Shape;531;p19"/>
           <p:cNvCxnSpPr/>
           <p:nvPr/>
         </p:nvCxnSpPr>
@@ -18335,7 +18504,7 @@
       </p:sp>
       <p:cxnSp>
         <p:nvCxnSpPr>
-          <p:cNvPr id="581" name="Google Shape;568;p20"/>
+          <p:cNvPr id="588" name="Google Shape;568;p20"/>
           <p:cNvCxnSpPr/>
           <p:nvPr/>
         </p:nvCxnSpPr>
@@ -19294,7 +19463,7 @@
       </p:sp>
       <p:cxnSp>
         <p:nvCxnSpPr>
-          <p:cNvPr id="608" name="Google Shape;586;p21"/>
+          <p:cNvPr id="615" name="Google Shape;586;p21"/>
           <p:cNvCxnSpPr/>
           <p:nvPr/>
         </p:nvCxnSpPr>
@@ -20575,7 +20744,7 @@
       </p:sp>
       <p:cxnSp>
         <p:nvCxnSpPr>
-          <p:cNvPr id="60" name="Google Shape;35;p4"/>
+          <p:cNvPr id="67" name="Google Shape;35;p4"/>
           <p:cNvCxnSpPr/>
           <p:nvPr/>
         </p:nvCxnSpPr>
@@ -22027,7 +22196,7 @@
       </p:sp>
       <p:cxnSp>
         <p:nvCxnSpPr>
-          <p:cNvPr id="645" name="Google Shape;613;p22"/>
+          <p:cNvPr id="652" name="Google Shape;613;p22"/>
           <p:cNvCxnSpPr/>
           <p:nvPr/>
         </p:nvCxnSpPr>
@@ -23882,7 +24051,7 @@
       </p:sp>
       <p:cxnSp>
         <p:nvCxnSpPr>
-          <p:cNvPr id="668" name="Google Shape;650;p23"/>
+          <p:cNvPr id="675" name="Google Shape;650;p23"/>
           <p:cNvCxnSpPr/>
           <p:nvPr/>
         </p:nvCxnSpPr>
@@ -25058,7 +25227,7 @@
       </p:sp>
       <p:cxnSp>
         <p:nvCxnSpPr>
-          <p:cNvPr id="684" name="Google Shape;673;p24"/>
+          <p:cNvPr id="691" name="Google Shape;673;p24"/>
           <p:cNvCxnSpPr/>
           <p:nvPr/>
         </p:nvCxnSpPr>
@@ -25759,7 +25928,7 @@
       </p:sp>
       <p:cxnSp>
         <p:nvCxnSpPr>
-          <p:cNvPr id="92" name="Google Shape;65;p5"/>
+          <p:cNvPr id="99" name="Google Shape;65;p5"/>
           <p:cNvCxnSpPr/>
           <p:nvPr/>
         </p:nvCxnSpPr>
@@ -27327,7 +27496,7 @@
       </p:sp>
       <p:cxnSp>
         <p:nvCxnSpPr>
-          <p:cNvPr id="133" name="Google Shape;97;p6"/>
+          <p:cNvPr id="140" name="Google Shape;97;p6"/>
           <p:cNvCxnSpPr/>
           <p:nvPr/>
         </p:nvCxnSpPr>
@@ -29414,7 +29583,7 @@
       </p:sp>
       <p:cxnSp>
         <p:nvCxnSpPr>
-          <p:cNvPr id="164" name="Google Shape;138;p7"/>
+          <p:cNvPr id="171" name="Google Shape;138;p7"/>
           <p:cNvCxnSpPr/>
           <p:nvPr/>
         </p:nvCxnSpPr>
@@ -30927,7 +31096,7 @@
       </p:sp>
       <p:cxnSp>
         <p:nvCxnSpPr>
-          <p:cNvPr id="197" name="Google Shape;169;p8"/>
+          <p:cNvPr id="204" name="Google Shape;169;p8"/>
           <p:cNvCxnSpPr/>
           <p:nvPr/>
         </p:nvCxnSpPr>
@@ -32556,7 +32725,7 @@
       </p:sp>
       <p:cxnSp>
         <p:nvCxnSpPr>
-          <p:cNvPr id="224" name="Google Shape;202;p9"/>
+          <p:cNvPr id="231" name="Google Shape;202;p9"/>
           <p:cNvCxnSpPr/>
           <p:nvPr/>
         </p:nvCxnSpPr>
@@ -33837,7 +34006,7 @@
       </p:sp>
       <p:cxnSp>
         <p:nvCxnSpPr>
-          <p:cNvPr id="259" name="Google Shape;229;p10"/>
+          <p:cNvPr id="266" name="Google Shape;229;p10"/>
           <p:cNvCxnSpPr/>
           <p:nvPr/>
         </p:nvCxnSpPr>
@@ -35582,7 +35751,7 @@
       </p:sp>
       <p:cxnSp>
         <p:nvCxnSpPr>
-          <p:cNvPr id="282" name="Google Shape;264;p11"/>
+          <p:cNvPr id="289" name="Google Shape;264;p11"/>
           <p:cNvCxnSpPr/>
           <p:nvPr/>
         </p:nvCxnSpPr>

</xml_diff>